<commit_message>
Update royal leaders layout: Place King Salman in the center card across all reports and presentations
</commit_message>
<xml_diff>
--- a/التقرير_الاحترافي_المطور/عرض_تقديمي_جمعية_طبيبي_٢٠٢٦_النسخة_التنفيذية.pptx
+++ b/التقرير_الاحترافي_المطور/عرض_تقديمي_جمعية_طبيبي_٢٠٢٦_النسخة_التنفيذية.pptx
@@ -3316,7 +3316,7 @@
       </p:sp>
       <p:pic>
         <p:nvPicPr>
-          <p:cNvPr id="4" name="Picture 3" descr="king_salman.jpg"/>
+          <p:cNvPr id="4" name="Picture 3" descr="crown_prince.jpg"/>
           <p:cNvPicPr>
             <a:picLocks noChangeAspect="1"/>
           </p:cNvPicPr>
@@ -3368,8 +3368,8 @@
                 </a:solidFill>
                 <a:latin typeface="Cairo"/>
               </a:rPr>
-              <a:t>خادم الحرمين الشريفين
-الملك سلمان بن عبدالعزيز آل سعود
+              <a:t>صاحب السمو الملكي
+الأمير محمد بن سلمان بن عبدالعزيز
 </a:t>
             </a:r>
           </a:p>
@@ -3382,7 +3382,7 @@
                 </a:solidFill>
                 <a:latin typeface="Cairo"/>
               </a:rPr>
-              <a:t>«ما يميز هذه البلاد هو حرص قادتها على الخير والتشجيع عليه، وما نراه من مؤسسات خيرية في مختلف المجالات… إلا جانبًا من الجوانب المشرقة لبلادنا.»</a:t>
+              <a:t>«نهدف للوصول إلى قطاع غير ربحي مهم، مبادر وداعم ومؤثر في التعليم والصحة والثقافة والمجالات البحثية، وسنعتمد عليه بشكل رئيسي.»</a:t>
             </a:r>
           </a:p>
         </p:txBody>
@@ -3434,7 +3434,7 @@
       </p:sp>
       <p:pic>
         <p:nvPicPr>
-          <p:cNvPr id="7" name="Picture 6" descr="crown_prince.jpg"/>
+          <p:cNvPr id="7" name="Picture 6" descr="king_salman.jpg"/>
           <p:cNvPicPr>
             <a:picLocks noChangeAspect="1"/>
           </p:cNvPicPr>
@@ -3486,8 +3486,8 @@
                 </a:solidFill>
                 <a:latin typeface="Cairo"/>
               </a:rPr>
-              <a:t>صاحب السمو الملكي
-الأمير محمد بن سلمان بن عبدالعزيز
+              <a:t>خادم الحرمين الشريفين
+الملك سلمان بن عبدالعزيز آل سعود
 </a:t>
             </a:r>
           </a:p>
@@ -3500,7 +3500,7 @@
                 </a:solidFill>
                 <a:latin typeface="Cairo"/>
               </a:rPr>
-              <a:t>«نهدف للوصول إلى قطاع غير ربحي مهم، مبادر وداعم ومؤثر في التعليم والصحة والثقافة والمجالات البحثية، وسنعتمد عليه بشكل رئيسي.»</a:t>
+              <a:t>«ما يميز هذه البلاد هو حرص قادتها على الخير والتشجيع عليه، وما نراه من مؤسسات خيرية في مختلف المجالات… إلا جانبًا من الجوانب المشرقة لبلادنا.»</a:t>
             </a:r>
           </a:p>
         </p:txBody>

</xml_diff>

<commit_message>
Center portrait images in Slide 2 across web slides and PPTX presentation
</commit_message>
<xml_diff>
--- a/التقرير_الاحترافي_المطور/عرض_تقديمي_جمعية_طبيبي_٢٠٢٦_النسخة_التنفيذية.pptx
+++ b/التقرير_الاحترافي_المطور/عرض_تقديمي_جمعية_طبيبي_٢٠٢٦_النسخة_التنفيذية.pptx
@@ -3217,16 +3217,40 @@
           </a:p>
         </p:txBody>
       </p:sp>
-      <p:sp>
-        <p:nvSpPr>
-          <p:cNvPr id="3" name="TextBox 2"/>
+      <p:pic>
+        <p:nvPicPr>
+          <p:cNvPr id="3" name="Picture 2" descr="crown_prince.jpg"/>
+          <p:cNvPicPr>
+            <a:picLocks noChangeAspect="1"/>
+          </p:cNvPicPr>
+          <p:nvPr/>
+        </p:nvPicPr>
+        <p:blipFill>
+          <a:blip r:embed="rId2"/>
+          <a:stretch>
+            <a:fillRect/>
+          </a:stretch>
+        </p:blipFill>
+        <p:spPr>
+          <a:xfrm>
+            <a:off x="1783080" y="1371600"/>
+            <a:ext cx="1280160" cy="1280160"/>
+          </a:xfrm>
+          <a:prstGeom prst="rect">
+            <a:avLst/>
+          </a:prstGeom>
+        </p:spPr>
+      </p:pic>
+      <p:sp>
+        <p:nvSpPr>
+          <p:cNvPr id="4" name="TextBox 3"/>
           <p:cNvSpPr txBox="1"/>
           <p:nvPr/>
         </p:nvSpPr>
         <p:spPr>
           <a:xfrm>
-            <a:off x="731520" y="1463040"/>
-            <a:ext cx="3383280" cy="4572000"/>
+            <a:off x="731520" y="2788920"/>
+            <a:ext cx="3383280" cy="3474720"/>
           </a:xfrm>
           <a:prstGeom prst="rect">
             <a:avLst/>
@@ -3240,7 +3264,7 @@
           <a:lstStyle/>
           <a:p>
             <a:pPr algn="ctr">
-              <a:defRPr sz="1400" b="1">
+              <a:defRPr sz="1350" b="1">
                 <a:solidFill>
                   <a:srgbClr val="6B1D3A"/>
                 </a:solidFill>
@@ -3252,7 +3276,7 @@
           </a:p>
           <a:p>
             <a:pPr algn="ctr">
-              <a:defRPr sz="1100">
+              <a:defRPr sz="1050">
                 <a:solidFill>
                   <a:srgbClr val="C9A96E"/>
                 </a:solidFill>
@@ -3264,8 +3288,8 @@
           </a:p>
           <a:p>
             <a:br/>
-            <a:pPr algn="r">
-              <a:defRPr sz="1100" i="1">
+            <a:pPr algn="ctr">
+              <a:defRPr sz="1050" i="1">
                 <a:solidFill>
                   <a:srgbClr val="2D2D2D"/>
                 </a:solidFill>
@@ -3277,16 +3301,40 @@
           </a:p>
         </p:txBody>
       </p:sp>
-      <p:sp>
-        <p:nvSpPr>
-          <p:cNvPr id="4" name="TextBox 3"/>
+      <p:pic>
+        <p:nvPicPr>
+          <p:cNvPr id="5" name="Picture 4" descr="king_salman.jpg"/>
+          <p:cNvPicPr>
+            <a:picLocks noChangeAspect="1"/>
+          </p:cNvPicPr>
+          <p:nvPr/>
+        </p:nvPicPr>
+        <p:blipFill>
+          <a:blip r:embed="rId3"/>
+          <a:stretch>
+            <a:fillRect/>
+          </a:stretch>
+        </p:blipFill>
+        <p:spPr>
+          <a:xfrm>
+            <a:off x="5440679" y="1371600"/>
+            <a:ext cx="1280160" cy="1280160"/>
+          </a:xfrm>
+          <a:prstGeom prst="rect">
+            <a:avLst/>
+          </a:prstGeom>
+        </p:spPr>
+      </p:pic>
+      <p:sp>
+        <p:nvSpPr>
+          <p:cNvPr id="6" name="TextBox 5"/>
           <p:cNvSpPr txBox="1"/>
           <p:nvPr/>
         </p:nvSpPr>
         <p:spPr>
           <a:xfrm>
-            <a:off x="4389120" y="1463040"/>
-            <a:ext cx="3383280" cy="4572000"/>
+            <a:off x="4389120" y="2788920"/>
+            <a:ext cx="3383280" cy="3474720"/>
           </a:xfrm>
           <a:prstGeom prst="rect">
             <a:avLst/>
@@ -3300,7 +3348,7 @@
           <a:lstStyle/>
           <a:p>
             <a:pPr algn="ctr">
-              <a:defRPr sz="1400" b="1">
+              <a:defRPr sz="1350" b="1">
                 <a:solidFill>
                   <a:srgbClr val="6B1D3A"/>
                 </a:solidFill>
@@ -3312,7 +3360,7 @@
           </a:p>
           <a:p>
             <a:pPr algn="ctr">
-              <a:defRPr sz="1100">
+              <a:defRPr sz="1050">
                 <a:solidFill>
                   <a:srgbClr val="C9A96E"/>
                 </a:solidFill>
@@ -3324,8 +3372,8 @@
           </a:p>
           <a:p>
             <a:br/>
-            <a:pPr algn="r">
-              <a:defRPr sz="1100" i="1">
+            <a:pPr algn="ctr">
+              <a:defRPr sz="1050" i="1">
                 <a:solidFill>
                   <a:srgbClr val="2D2D2D"/>
                 </a:solidFill>
@@ -3337,16 +3385,40 @@
           </a:p>
         </p:txBody>
       </p:sp>
-      <p:sp>
-        <p:nvSpPr>
-          <p:cNvPr id="5" name="TextBox 4"/>
+      <p:pic>
+        <p:nvPicPr>
+          <p:cNvPr id="7" name="Picture 6" descr="prince_salman.jpg"/>
+          <p:cNvPicPr>
+            <a:picLocks noChangeAspect="1"/>
+          </p:cNvPicPr>
+          <p:nvPr/>
+        </p:nvPicPr>
+        <p:blipFill>
+          <a:blip r:embed="rId4"/>
+          <a:stretch>
+            <a:fillRect/>
+          </a:stretch>
+        </p:blipFill>
+        <p:spPr>
+          <a:xfrm>
+            <a:off x="9098280" y="1371600"/>
+            <a:ext cx="1280160" cy="1280160"/>
+          </a:xfrm>
+          <a:prstGeom prst="rect">
+            <a:avLst/>
+          </a:prstGeom>
+        </p:spPr>
+      </p:pic>
+      <p:sp>
+        <p:nvSpPr>
+          <p:cNvPr id="8" name="TextBox 7"/>
           <p:cNvSpPr txBox="1"/>
           <p:nvPr/>
         </p:nvSpPr>
         <p:spPr>
           <a:xfrm>
-            <a:off x="8046720" y="1463040"/>
-            <a:ext cx="3383280" cy="4572000"/>
+            <a:off x="8046720" y="2788920"/>
+            <a:ext cx="3383280" cy="3474720"/>
           </a:xfrm>
           <a:prstGeom prst="rect">
             <a:avLst/>
@@ -3360,7 +3432,7 @@
           <a:lstStyle/>
           <a:p>
             <a:pPr algn="ctr">
-              <a:defRPr sz="1400" b="1">
+              <a:defRPr sz="1350" b="1">
                 <a:solidFill>
                   <a:srgbClr val="6B1D3A"/>
                 </a:solidFill>
@@ -3372,7 +3444,7 @@
           </a:p>
           <a:p>
             <a:pPr algn="ctr">
-              <a:defRPr sz="1100">
+              <a:defRPr sz="1050">
                 <a:solidFill>
                   <a:srgbClr val="C9A96E"/>
                 </a:solidFill>
@@ -3384,8 +3456,8 @@
           </a:p>
           <a:p>
             <a:br/>
-            <a:pPr algn="r">
-              <a:defRPr sz="1100" i="1">
+            <a:pPr algn="ctr">
+              <a:defRPr sz="1050" i="1">
                 <a:solidFill>
                   <a:srgbClr val="2D2D2D"/>
                 </a:solidFill>

</xml_diff>